<commit_message>
update transport plotting scripts and figures
</commit_message>
<xml_diff>
--- a/vsc_transport_2026/plotting_scripts/figures/fig4.pptx
+++ b/vsc_transport_2026/plotting_scripts/figures/fig4.pptx
@@ -371,7 +371,7 @@
           <a:p>
             <a:fld id="{2D1C7617-E34A-4842-8F6D-F1887ACB9C3F}" type="datetimeFigureOut">
               <a:rPr lang="en-US" smtClean="0"/>
-              <a:t>6/23/26</a:t>
+              <a:t>8/15/26</a:t>
             </a:fld>
             <a:endParaRPr lang="en-US"/>
           </a:p>
@@ -569,7 +569,7 @@
           <a:p>
             <a:fld id="{2D1C7617-E34A-4842-8F6D-F1887ACB9C3F}" type="datetimeFigureOut">
               <a:rPr lang="en-US" smtClean="0"/>
-              <a:t>6/23/26</a:t>
+              <a:t>8/15/26</a:t>
             </a:fld>
             <a:endParaRPr lang="en-US"/>
           </a:p>
@@ -777,7 +777,7 @@
           <a:p>
             <a:fld id="{2D1C7617-E34A-4842-8F6D-F1887ACB9C3F}" type="datetimeFigureOut">
               <a:rPr lang="en-US" smtClean="0"/>
-              <a:t>6/23/26</a:t>
+              <a:t>8/15/26</a:t>
             </a:fld>
             <a:endParaRPr lang="en-US"/>
           </a:p>
@@ -975,7 +975,7 @@
           <a:p>
             <a:fld id="{2D1C7617-E34A-4842-8F6D-F1887ACB9C3F}" type="datetimeFigureOut">
               <a:rPr lang="en-US" smtClean="0"/>
-              <a:t>6/23/26</a:t>
+              <a:t>8/15/26</a:t>
             </a:fld>
             <a:endParaRPr lang="en-US"/>
           </a:p>
@@ -1250,7 +1250,7 @@
           <a:p>
             <a:fld id="{2D1C7617-E34A-4842-8F6D-F1887ACB9C3F}" type="datetimeFigureOut">
               <a:rPr lang="en-US" smtClean="0"/>
-              <a:t>6/23/26</a:t>
+              <a:t>8/15/26</a:t>
             </a:fld>
             <a:endParaRPr lang="en-US"/>
           </a:p>
@@ -1515,7 +1515,7 @@
           <a:p>
             <a:fld id="{2D1C7617-E34A-4842-8F6D-F1887ACB9C3F}" type="datetimeFigureOut">
               <a:rPr lang="en-US" smtClean="0"/>
-              <a:t>6/23/26</a:t>
+              <a:t>8/15/26</a:t>
             </a:fld>
             <a:endParaRPr lang="en-US"/>
           </a:p>
@@ -1927,7 +1927,7 @@
           <a:p>
             <a:fld id="{2D1C7617-E34A-4842-8F6D-F1887ACB9C3F}" type="datetimeFigureOut">
               <a:rPr lang="en-US" smtClean="0"/>
-              <a:t>6/23/26</a:t>
+              <a:t>8/15/26</a:t>
             </a:fld>
             <a:endParaRPr lang="en-US"/>
           </a:p>
@@ -2068,7 +2068,7 @@
           <a:p>
             <a:fld id="{2D1C7617-E34A-4842-8F6D-F1887ACB9C3F}" type="datetimeFigureOut">
               <a:rPr lang="en-US" smtClean="0"/>
-              <a:t>6/23/26</a:t>
+              <a:t>8/15/26</a:t>
             </a:fld>
             <a:endParaRPr lang="en-US"/>
           </a:p>
@@ -2181,7 +2181,7 @@
           <a:p>
             <a:fld id="{2D1C7617-E34A-4842-8F6D-F1887ACB9C3F}" type="datetimeFigureOut">
               <a:rPr lang="en-US" smtClean="0"/>
-              <a:t>6/23/26</a:t>
+              <a:t>8/15/26</a:t>
             </a:fld>
             <a:endParaRPr lang="en-US"/>
           </a:p>
@@ -2492,7 +2492,7 @@
           <a:p>
             <a:fld id="{2D1C7617-E34A-4842-8F6D-F1887ACB9C3F}" type="datetimeFigureOut">
               <a:rPr lang="en-US" smtClean="0"/>
-              <a:t>6/23/26</a:t>
+              <a:t>8/15/26</a:t>
             </a:fld>
             <a:endParaRPr lang="en-US"/>
           </a:p>
@@ -2780,7 +2780,7 @@
           <a:p>
             <a:fld id="{2D1C7617-E34A-4842-8F6D-F1887ACB9C3F}" type="datetimeFigureOut">
               <a:rPr lang="en-US" smtClean="0"/>
-              <a:t>6/23/26</a:t>
+              <a:t>8/15/26</a:t>
             </a:fld>
             <a:endParaRPr lang="en-US"/>
           </a:p>
@@ -3021,7 +3021,7 @@
           <a:p>
             <a:fld id="{2D1C7617-E34A-4842-8F6D-F1887ACB9C3F}" type="datetimeFigureOut">
               <a:rPr lang="en-US" smtClean="0"/>
-              <a:t>6/23/26</a:t>
+              <a:t>8/15/26</a:t>
             </a:fld>
             <a:endParaRPr lang="en-US"/>
           </a:p>
@@ -3440,10 +3440,10 @@
       </p:grpSpPr>
       <p:grpSp>
         <p:nvGrpSpPr>
-          <p:cNvPr id="44" name="Group 43">
+          <p:cNvPr id="46" name="Group 45">
             <a:extLst>
               <a:ext uri="{FF2B5EF4-FFF2-40B4-BE49-F238E27FC236}">
-                <a16:creationId xmlns:a16="http://schemas.microsoft.com/office/drawing/2014/main" id="{C6FF2EAC-E8E8-11B3-FAFE-9BB5BCE047E9}"/>
+                <a16:creationId xmlns:a16="http://schemas.microsoft.com/office/drawing/2014/main" id="{F861FC45-018A-CB2E-C42A-6AC5726081E0}"/>
               </a:ext>
             </a:extLst>
           </p:cNvPr>
@@ -3452,18 +3452,18 @@
         </p:nvGrpSpPr>
         <p:grpSpPr>
           <a:xfrm>
-            <a:off x="4335790" y="-254001"/>
+            <a:off x="3666923" y="-110066"/>
             <a:ext cx="6703888" cy="6858000"/>
-            <a:chOff x="4335790" y="-262467"/>
+            <a:chOff x="4335789" y="-262466"/>
             <a:chExt cx="6703888" cy="6858000"/>
           </a:xfrm>
         </p:grpSpPr>
         <p:pic>
           <p:nvPicPr>
-            <p:cNvPr id="43" name="Picture 42">
+            <p:cNvPr id="40" name="Picture 39">
               <a:extLst>
                 <a:ext uri="{FF2B5EF4-FFF2-40B4-BE49-F238E27FC236}">
-                  <a16:creationId xmlns:a16="http://schemas.microsoft.com/office/drawing/2014/main" id="{6985F76E-882D-50EB-1E3B-6B3195BB5A39}"/>
+                  <a16:creationId xmlns:a16="http://schemas.microsoft.com/office/drawing/2014/main" id="{00943CCA-9F11-FCB5-4FD7-855CF3244D2B}"/>
                 </a:ext>
               </a:extLst>
             </p:cNvPr>
@@ -3480,7 +3480,7 @@
           </p:blipFill>
           <p:spPr>
             <a:xfrm>
-              <a:off x="4335790" y="-262467"/>
+              <a:off x="4335789" y="-262466"/>
               <a:ext cx="6703888" cy="6858000"/>
             </a:xfrm>
             <a:prstGeom prst="rect">
@@ -3502,7 +3502,7 @@
           </p:nvGrpSpPr>
           <p:grpSpPr>
             <a:xfrm>
-              <a:off x="6082402" y="3933135"/>
+              <a:off x="6082402" y="3941601"/>
               <a:ext cx="4305111" cy="2504639"/>
               <a:chOff x="6082402" y="3933135"/>
               <a:chExt cx="4305111" cy="2504639"/>

</xml_diff>